<commit_message>
Fix Aurora example timeline coherence across decks 01-09
Resequence freeze (4/10) before silicon (5/12) and farm-ROI lagging
KPIs before ask-by (5/30). Add AURORA_TIMELINE anchors and regression
tests that fail on freeze-held-after-ask and 01/02 chronology bugs.
</commit_message>
<xml_diff>
--- a/skills/presentations/assets/pptx/examples/01-technical-review.pptx
+++ b/skills/presentations/assets/pptx/examples/01-technical-review.pptx
@@ -5,16 +5,16 @@
     <p:sldMasterId xmlns:r="http://schemas.openxmlformats.org/officeDocument/2006/relationships" id="2147483648" r:id="rId1"/>
   </p:sldMasterIdLst>
   <p:notesMasterIdLst>
-    <p:notesMasterId r:id="R2445a5700fd24b7d"/>
+    <p:notesMasterId r:id="R8842eded6b1041de"/>
   </p:notesMasterIdLst>
   <p:sldIdLst>
-    <p:sldId id="256" r:id="R55c315e8f86d4dce"/>
-    <p:sldId id="257" r:id="R36979982603042b6"/>
-    <p:sldId id="258" r:id="R9748cbeb080c4824"/>
-    <p:sldId id="259" r:id="R4571f3588e0844f7"/>
-    <p:sldId id="260" r:id="Re07854eed8f64a1a"/>
-    <p:sldId id="261" r:id="Rf918f64af8664ee9"/>
-    <p:sldId id="262" r:id="R8f8f13b3460345a2"/>
+    <p:sldId id="256" r:id="Rc0004b558a3c4171"/>
+    <p:sldId id="257" r:id="Rbd305dec5d2a464f"/>
+    <p:sldId id="258" r:id="Rbe888182aa2d4bb0"/>
+    <p:sldId id="259" r:id="Rfcea54941b444228"/>
+    <p:sldId id="260" r:id="R73e5717c33244cdc"/>
+    <p:sldId id="261" r:id="R35a38e641cad4524"/>
+    <p:sldId id="262" r:id="R0f543aa44c184a26"/>
   </p:sldIdLst>
   <p:sldSz cx="12192000" cy="6858000"/>
   <p:notesSz cx="6858000" cy="9144000"/>
@@ -1218,7 +1218,7 @@
                 <a:latin typeface="Calibri"/>
                 <a:ea typeface="Calibri"/>
               </a:rPr>
-              <a:t>Design freeze for AON clock mux — needed before RTL freeze 2026-06-20</a:t>
+              <a:t>Design freeze for AON clock mux — needed before RTL freeze 2026-04-10</a:t>
             </a:r>
           </a:p>
         </p:txBody>
@@ -1371,7 +1371,7 @@
                 <a:latin typeface="Calibri"/>
                 <a:ea typeface="Calibri"/>
               </a:rPr>
-              <a:t>Status: YELLOW  ·  Recommend Option B  ·  Decide by Fri 2026-05-16 (Morgan)</a:t>
+              <a:t>Status: YELLOW  ·  Recommend Option B  ·  Decide by Fri 2026-03-20 (Morgan)</a:t>
             </a:r>
           </a:p>
         </p:txBody>
@@ -1430,7 +1430,7 @@
                 <a:latin typeface="Calibri"/>
                 <a:ea typeface="Calibri"/>
               </a:rPr>
-              <a:t>Difficulty: Full dual-source mux + glitchless switch needs +3 eng-weeks and threatens 6/20 freeze.</a:t>
+              <a:t>Difficulty: Full dual-source mux + glitchless switch needs +3 eng-weeks and threatens 4/10 freeze.</a:t>
             </a:r>
           </a:p>
           <a:p xmlns:a="http://schemas.openxmlformats.org/drawingml/2006/main">
@@ -1623,7 +1623,7 @@
                 <a:latin typeface="Calibri"/>
                 <a:ea typeface="Calibri"/>
               </a:rPr>
-              <a:t>Success: AON boots glitch-free across 3 corners in UVM; RTL freeze stays 6/20.</a:t>
+              <a:t>Success: AON boots glitch-free across 3 corners in UVM; RTL freeze stays 4/10.</a:t>
             </a:r>
           </a:p>
           <a:p xmlns:a="http://schemas.openxmlformats.org/drawingml/2006/main">
@@ -1647,7 +1647,7 @@
                 <a:latin typeface="Calibri"/>
                 <a:ea typeface="Calibri"/>
               </a:rPr>
-              <a:t>Constraints: freeze 6/20 · package power budget · PMIC IP delivers 5/28 · Atlas has 2 clock experts.</a:t>
+              <a:t>Constraints: freeze 4/10 · package power budget · PMIC IP delivers 3/28 · Atlas has 2 clock experts.</a:t>
             </a:r>
           </a:p>
         </p:txBody>
@@ -1973,7 +1973,7 @@
                 <a:latin typeface="Calibri"/>
                 <a:ea typeface="Calibri"/>
               </a:rPr>
-              <a:t>2. Late PMIC IP change — mitigate: freeze interface table 5/28; owner: Ken (IP).</a:t>
+              <a:t>2. Late PMIC IP change — mitigate: freeze interface table 3/28; owner: Ken (IP).</a:t>
             </a:r>
           </a:p>
           <a:p xmlns:a="http://schemas.openxmlformats.org/drawingml/2006/main">
@@ -2330,7 +2330,7 @@
                           <a:latin typeface="Calibri"/>
                           <a:ea typeface="Calibri"/>
                         </a:rPr>
-                        <a:t>Freeze → 7/04</a:t>
+                        <a:t>Freeze → 5/01</a:t>
                       </a:r>
                     </a:p>
                   </a:txBody>
@@ -2447,7 +2447,7 @@
                           <a:latin typeface="Calibri"/>
                           <a:ea typeface="Calibri"/>
                         </a:rPr>
-                        <a:t>Freeze 6/20 holds</a:t>
+                        <a:t>Freeze 4/10 holds</a:t>
                       </a:r>
                     </a:p>
                   </a:txBody>
@@ -2797,7 +2797,7 @@
                 <a:latin typeface="Calibri"/>
                 <a:ea typeface="Calibri"/>
               </a:rPr>
-              <a:t>By: Friday 2026-05-16 EOD.</a:t>
+              <a:t>By: Friday 2026-03-20 EOD.</a:t>
             </a:r>
           </a:p>
           <a:p xmlns:a="http://schemas.openxmlformats.org/drawingml/2006/main">

</xml_diff>

<commit_message>
Add explicit public pattern provenance and fix broken asset links
Each template/example deck now has a Pattern provenance slide and cover
line; outline MDs cite sources. Fix assets/README paths to pptx/templates
and pptx/examples; add scripts/check_markdown_links.py (all 22 URLs 200).
</commit_message>
<xml_diff>
--- a/skills/presentations/assets/pptx/examples/01-technical-review.pptx
+++ b/skills/presentations/assets/pptx/examples/01-technical-review.pptx
@@ -5,16 +5,17 @@
     <p:sldMasterId xmlns:r="http://schemas.openxmlformats.org/officeDocument/2006/relationships" id="2147483648" r:id="rId1"/>
   </p:sldMasterIdLst>
   <p:notesMasterIdLst>
-    <p:notesMasterId r:id="R8842eded6b1041de"/>
+    <p:notesMasterId r:id="R956c1dee84b046f9"/>
   </p:notesMasterIdLst>
   <p:sldIdLst>
-    <p:sldId id="256" r:id="Rc0004b558a3c4171"/>
-    <p:sldId id="257" r:id="Rbd305dec5d2a464f"/>
-    <p:sldId id="258" r:id="Rbe888182aa2d4bb0"/>
-    <p:sldId id="259" r:id="Rfcea54941b444228"/>
-    <p:sldId id="260" r:id="R73e5717c33244cdc"/>
-    <p:sldId id="261" r:id="R35a38e641cad4524"/>
-    <p:sldId id="262" r:id="R0f543aa44c184a26"/>
+    <p:sldId id="256" r:id="R04e2db6b0334436c"/>
+    <p:sldId id="257" r:id="R4063417af8ac454b"/>
+    <p:sldId id="258" r:id="Re2e05036ed664316"/>
+    <p:sldId id="259" r:id="R434c96df45f74d16"/>
+    <p:sldId id="260" r:id="Re92582b376ed4107"/>
+    <p:sldId id="261" r:id="Raf60c322de6e48e3"/>
+    <p:sldId id="262" r:id="R544065e46e254399"/>
+    <p:sldId id="263" r:id="Rc997902de75946ce"/>
   </p:sldIdLst>
   <p:sldSz cx="12192000" cy="6858000"/>
   <p:notesSz cx="6858000" cy="9144000"/>
@@ -480,6 +481,30 @@
               <a:t>Cover (example). Aurora AON clock: freeze on time via phased strap, dual-mux deferred to revB.</a:t>
             </a:r>
           </a:p>
+          <a:p xmlns:a="http://schemas.openxmlformats.org/drawingml/2006/main">
+            <a:r>
+              <a:rPr lang="en-US"/>
+              <a:t/>
+            </a:r>
+          </a:p>
+          <a:p xmlns:a="http://schemas.openxmlformats.org/drawingml/2006/main">
+            <a:r>
+              <a:rPr lang="en-US"/>
+              <a:t>Design-doc / RFC options table + residual risk</a:t>
+            </a:r>
+          </a:p>
+          <a:p xmlns:a="http://schemas.openxmlformats.org/drawingml/2006/main">
+            <a:r>
+              <a:rPr lang="en-US"/>
+              <a:t>StaffEng — Writing engineering strategy: https://staffeng.com/guides/engineering-strategy/</a:t>
+            </a:r>
+          </a:p>
+          <a:p xmlns:a="http://schemas.openxmlformats.org/drawingml/2006/main">
+            <a:r>
+              <a:rPr lang="en-US"/>
+              <a:t>Utterskills — options instead of single conclusion: https://utterskills.com/blog/communication-skills-for-software-engineers</a:t>
+            </a:r>
+          </a:p>
         </p:txBody>
       </p:sp>
     </p:spTree>
@@ -532,7 +557,19 @@
           <a:p xmlns:a="http://schemas.openxmlformats.org/drawingml/2006/main">
             <a:r>
               <a:rPr lang="en-US"/>
-              <a:t>Land B; do not re-open full dual-mux design in this room.</a:t>
+              <a:t>Design-doc / RFC options table + residual risk</a:t>
+            </a:r>
+          </a:p>
+          <a:p xmlns:a="http://schemas.openxmlformats.org/drawingml/2006/main">
+            <a:r>
+              <a:rPr lang="en-US"/>
+              <a:t>StaffEng — Writing engineering strategy: https://staffeng.com/guides/engineering-strategy/</a:t>
+            </a:r>
+          </a:p>
+          <a:p xmlns:a="http://schemas.openxmlformats.org/drawingml/2006/main">
+            <a:r>
+              <a:rPr lang="en-US"/>
+              <a:t>Utterskills — options instead of single conclusion: https://utterskills.com/blog/communication-skills-for-software-engineers</a:t>
             </a:r>
           </a:p>
         </p:txBody>
@@ -587,7 +624,7 @@
           <a:p xmlns:a="http://schemas.openxmlformats.org/drawingml/2006/main">
             <a:r>
               <a:rPr lang="en-US"/>
-              <a:t>Customer SKU power-exit is the business hook.</a:t>
+              <a:t>Land B; do not re-open full dual-mux design in this room.</a:t>
             </a:r>
           </a:p>
         </p:txBody>
@@ -642,7 +679,7 @@
           <a:p xmlns:a="http://schemas.openxmlformats.org/drawingml/2006/main">
             <a:r>
               <a:rPr lang="en-US"/>
-              <a:t>One page; point to RFC-AURORA-117 for waveforms.</a:t>
+              <a:t>Customer SKU power-exit is the business hook.</a:t>
             </a:r>
           </a:p>
         </p:txBody>
@@ -697,7 +734,7 @@
           <a:p xmlns:a="http://schemas.openxmlformats.org/drawingml/2006/main">
             <a:r>
               <a:rPr lang="en-US"/>
-              <a:t>Residual risk is explicit for silicon.</a:t>
+              <a:t>One page; point to RFC-AURORA-117 for waveforms.</a:t>
             </a:r>
           </a:p>
         </p:txBody>
@@ -752,7 +789,7 @@
           <a:p xmlns:a="http://schemas.openxmlformats.org/drawingml/2006/main">
             <a:r>
               <a:rPr lang="en-US"/>
-              <a:t>Walk trade-offs; land recommendation.</a:t>
+              <a:t>Residual risk is explicit for silicon.</a:t>
             </a:r>
           </a:p>
         </p:txBody>
@@ -766,6 +803,61 @@
 </file>
 
 <file path=ppt/notesSlides/notesSlide7.xml><?xml version="1.0" encoding="utf-8"?>
+<p:notes xmlns:p="http://schemas.openxmlformats.org/presentationml/2006/main">
+  <p:cSld>
+    <p:spTree>
+      <p:nvGrpSpPr>
+        <p:cNvPr id="1" name=""/>
+        <p:cNvGrpSpPr/>
+        <p:nvPr/>
+      </p:nvGrpSpPr>
+      <p:grpSpPr>
+        <a:xfrm xmlns:a="http://schemas.openxmlformats.org/drawingml/2006/main"/>
+      </p:grpSpPr>
+      <p:sp>
+        <p:nvSpPr>
+          <p:cNvPr id="2" name="Slide Image Placeholder 1"/>
+          <p:cNvSpPr/>
+          <p:nvPr>
+            <p:ph type="sldImg" idx="0"/>
+          </p:nvPr>
+        </p:nvSpPr>
+        <p:spPr/>
+        <p:txBody>
+          <a:bodyPr xmlns:a="http://schemas.openxmlformats.org/drawingml/2006/main"/>
+          <a:lstStyle xmlns:a="http://schemas.openxmlformats.org/drawingml/2006/main"/>
+          <a:p xmlns:a="http://schemas.openxmlformats.org/drawingml/2006/main"/>
+        </p:txBody>
+      </p:sp>
+      <p:sp>
+        <p:nvSpPr>
+          <p:cNvPr id="3" name="Notes Placeholder 2"/>
+          <p:cNvSpPr/>
+          <p:nvPr>
+            <p:ph type="body" idx="1"/>
+          </p:nvPr>
+        </p:nvSpPr>
+        <p:spPr/>
+        <p:txBody>
+          <a:bodyPr xmlns:a="http://schemas.openxmlformats.org/drawingml/2006/main"/>
+          <a:lstStyle xmlns:a="http://schemas.openxmlformats.org/drawingml/2006/main"/>
+          <a:p xmlns:a="http://schemas.openxmlformats.org/drawingml/2006/main">
+            <a:r>
+              <a:rPr lang="en-US"/>
+              <a:t>Walk trade-offs; land recommendation.</a:t>
+            </a:r>
+          </a:p>
+        </p:txBody>
+      </p:sp>
+    </p:spTree>
+  </p:cSld>
+  <p:clrMapOvr>
+    <a:masterClrMapping xmlns:a="http://schemas.openxmlformats.org/drawingml/2006/main"/>
+  </p:clrMapOvr>
+</p:notes>
+</file>
+
+<file path=ppt/notesSlides/notesSlide8.xml><?xml version="1.0" encoding="utf-8"?>
 <p:notes xmlns:p="http://schemas.openxmlformats.org/presentationml/2006/main">
   <p:cSld>
     <p:spTree>
@@ -1135,8 +1227,8 @@
         </p:nvSpPr>
         <p:spPr>
           <a:xfrm xmlns:a="http://schemas.openxmlformats.org/drawingml/2006/main">
-            <a:off x="504000" y="1008000"/>
-            <a:ext cx="11088000" cy="324000"/>
+            <a:off x="504000" y="936000"/>
+            <a:ext cx="11088000" cy="306000"/>
           </a:xfrm>
           <a:prstGeom xmlns:a="http://schemas.openxmlformats.org/drawingml/2006/main" prst="rect">
             <a:avLst/>
@@ -1167,8 +1259,8 @@
         </p:nvSpPr>
         <p:spPr>
           <a:xfrm xmlns:a="http://schemas.openxmlformats.org/drawingml/2006/main">
-            <a:off x="504000" y="1440000"/>
-            <a:ext cx="11088000" cy="936000"/>
+            <a:off x="504000" y="1332000"/>
+            <a:ext cx="11088000" cy="900000"/>
           </a:xfrm>
           <a:prstGeom xmlns:a="http://schemas.openxmlformats.org/drawingml/2006/main" prst="rect">
             <a:avLst/>
@@ -1179,7 +1271,7 @@
           <a:lstStyle xmlns:a="http://schemas.openxmlformats.org/drawingml/2006/main"/>
           <a:p xmlns:a="http://schemas.openxmlformats.org/drawingml/2006/main">
             <a:r>
-              <a:rPr lang="en-US" sz="3400" b="1">
+              <a:rPr lang="en-US" sz="3200" b="1">
                 <a:solidFill>
                   <a:srgbClr val="FFFFFF"/>
                 </a:solidFill>
@@ -1199,8 +1291,8 @@
         </p:nvSpPr>
         <p:spPr>
           <a:xfrm xmlns:a="http://schemas.openxmlformats.org/drawingml/2006/main">
-            <a:off x="504000" y="2520000"/>
-            <a:ext cx="11088000" cy="720000"/>
+            <a:off x="504000" y="2340000"/>
+            <a:ext cx="11088000" cy="648000"/>
           </a:xfrm>
           <a:prstGeom xmlns:a="http://schemas.openxmlformats.org/drawingml/2006/main" prst="rect">
             <a:avLst/>
@@ -1211,7 +1303,7 @@
           <a:lstStyle xmlns:a="http://schemas.openxmlformats.org/drawingml/2006/main"/>
           <a:p xmlns:a="http://schemas.openxmlformats.org/drawingml/2006/main">
             <a:r>
-              <a:rPr lang="en-US" sz="1700" b="0">
+              <a:rPr lang="en-US" sz="1600" b="0">
                 <a:solidFill>
                   <a:srgbClr val="CADCFC"/>
                 </a:solidFill>
@@ -1226,6 +1318,38 @@
       <p:sp>
         <p:nvSpPr>
           <p:cNvPr id="100003" name="TextBox 4"/>
+          <p:cNvSpPr txBox="1"/>
+          <p:nvPr/>
+        </p:nvSpPr>
+        <p:spPr>
+          <a:xfrm xmlns:a="http://schemas.openxmlformats.org/drawingml/2006/main">
+            <a:off x="504000" y="3240000"/>
+            <a:ext cx="11088000" cy="576000"/>
+          </a:xfrm>
+          <a:prstGeom xmlns:a="http://schemas.openxmlformats.org/drawingml/2006/main" prst="rect">
+            <a:avLst/>
+          </a:prstGeom>
+        </p:spPr>
+        <p:txBody>
+          <a:bodyPr xmlns:a="http://schemas.openxmlformats.org/drawingml/2006/main"/>
+          <a:lstStyle xmlns:a="http://schemas.openxmlformats.org/drawingml/2006/main"/>
+          <a:p xmlns:a="http://schemas.openxmlformats.org/drawingml/2006/main">
+            <a:r>
+              <a:rPr lang="en-US" sz="1400" b="0">
+                <a:solidFill>
+                  <a:srgbClr val="A0C4E8"/>
+                </a:solidFill>
+                <a:latin typeface="Calibri"/>
+                <a:ea typeface="Calibri"/>
+              </a:rPr>
+              <a:t>Pattern: Design-doc / RFC options table + residual risk</a:t>
+            </a:r>
+          </a:p>
+        </p:txBody>
+      </p:sp>
+      <p:sp>
+        <p:nvSpPr>
+          <p:cNvPr id="100004" name="TextBox 5"/>
           <p:cNvSpPr txBox="1"/>
           <p:nvPr/>
         </p:nvSpPr>
@@ -1261,6 +1385,279 @@
 </file>
 
 <file path=ppt/slides/slide2.xml><?xml version="1.0" encoding="utf-8"?>
+<p:sld xmlns:p="http://schemas.openxmlformats.org/presentationml/2006/main">
+  <p:cSld name="Pattern provenance">
+    <p:bg>
+      <p:bgPr>
+        <a:solidFill xmlns:a="http://schemas.openxmlformats.org/drawingml/2006/main">
+          <a:srgbClr val="F4F7FC"/>
+        </a:solidFill>
+      </p:bgPr>
+    </p:bg>
+    <p:spTree>
+      <p:nvGrpSpPr>
+        <p:cNvPr id="1" name=""/>
+        <p:cNvGrpSpPr/>
+        <p:nvPr/>
+      </p:nvGrpSpPr>
+      <p:grpSpPr/>
+      <p:sp>
+        <p:nvSpPr>
+          <p:cNvPr id="100005" name="TextBox 1"/>
+          <p:cNvSpPr txBox="1"/>
+          <p:nvPr/>
+        </p:nvSpPr>
+        <p:spPr>
+          <a:xfrm xmlns:a="http://schemas.openxmlformats.org/drawingml/2006/main">
+            <a:off x="504000" y="270000"/>
+            <a:ext cx="11088000" cy="270000"/>
+          </a:xfrm>
+          <a:prstGeom xmlns:a="http://schemas.openxmlformats.org/drawingml/2006/main" prst="rect">
+            <a:avLst/>
+          </a:prstGeom>
+        </p:spPr>
+        <p:txBody>
+          <a:bodyPr xmlns:a="http://schemas.openxmlformats.org/drawingml/2006/main"/>
+          <a:lstStyle xmlns:a="http://schemas.openxmlformats.org/drawingml/2006/main"/>
+          <a:p xmlns:a="http://schemas.openxmlformats.org/drawingml/2006/main">
+            <a:r>
+              <a:rPr lang="en-US" sz="1100" b="1">
+                <a:solidFill>
+                  <a:srgbClr val="2B6CB0"/>
+                </a:solidFill>
+                <a:latin typeface="Calibri"/>
+                <a:ea typeface="Calibri"/>
+              </a:rPr>
+              <a:t>WHERE THIS DECK SHAPE COMES FROM</a:t>
+            </a:r>
+          </a:p>
+        </p:txBody>
+      </p:sp>
+      <p:sp>
+        <p:nvSpPr>
+          <p:cNvPr id="100006" name="TextBox 2"/>
+          <p:cNvSpPr txBox="1"/>
+          <p:nvPr/>
+        </p:nvSpPr>
+        <p:spPr>
+          <a:xfrm xmlns:a="http://schemas.openxmlformats.org/drawingml/2006/main">
+            <a:off x="504000" y="558000"/>
+            <a:ext cx="11088000" cy="612000"/>
+          </a:xfrm>
+          <a:prstGeom xmlns:a="http://schemas.openxmlformats.org/drawingml/2006/main" prst="rect">
+            <a:avLst/>
+          </a:prstGeom>
+        </p:spPr>
+        <p:txBody>
+          <a:bodyPr xmlns:a="http://schemas.openxmlformats.org/drawingml/2006/main"/>
+          <a:lstStyle xmlns:a="http://schemas.openxmlformats.org/drawingml/2006/main"/>
+          <a:p xmlns:a="http://schemas.openxmlformats.org/drawingml/2006/main">
+            <a:r>
+              <a:rPr lang="en-US" sz="2800" b="1">
+                <a:solidFill>
+                  <a:srgbClr val="1A202C"/>
+                </a:solidFill>
+                <a:latin typeface="Calibri"/>
+                <a:ea typeface="Calibri"/>
+              </a:rPr>
+              <a:t>Pattern provenance</a:t>
+            </a:r>
+          </a:p>
+        </p:txBody>
+      </p:sp>
+      <p:sp>
+        <p:nvSpPr>
+          <p:cNvPr id="100007" name="TextBox 3"/>
+          <p:cNvSpPr txBox="1"/>
+          <p:nvPr/>
+        </p:nvSpPr>
+        <p:spPr>
+          <a:xfrm xmlns:a="http://schemas.openxmlformats.org/drawingml/2006/main">
+            <a:off x="504000" y="1260000"/>
+            <a:ext cx="11088000" cy="4860000"/>
+          </a:xfrm>
+          <a:prstGeom xmlns:a="http://schemas.openxmlformats.org/drawingml/2006/main" prst="rect">
+            <a:avLst/>
+          </a:prstGeom>
+          <a:solidFill xmlns:a="http://schemas.openxmlformats.org/drawingml/2006/main">
+            <a:srgbClr val="FFFFFF"/>
+          </a:solidFill>
+        </p:spPr>
+        <p:txBody>
+          <a:bodyPr xmlns:a="http://schemas.openxmlformats.org/drawingml/2006/main"/>
+          <a:lstStyle xmlns:a="http://schemas.openxmlformats.org/drawingml/2006/main"/>
+          <a:p xmlns:a="http://schemas.openxmlformats.org/drawingml/2006/main">
+            <a:r>
+              <a:rPr lang="en-US" sz="1500" b="0">
+                <a:solidFill>
+                  <a:srgbClr val="1A202C"/>
+                </a:solidFill>
+                <a:latin typeface="Calibri"/>
+                <a:ea typeface="Calibri"/>
+              </a:rPr>
+              <a:t>Public pattern (structure only — not a confidential company deck):</a:t>
+            </a:r>
+          </a:p>
+          <a:p xmlns:a="http://schemas.openxmlformats.org/drawingml/2006/main">
+            <a:r>
+              <a:rPr lang="en-US" sz="1500" b="0">
+                <a:solidFill>
+                  <a:srgbClr val="1A202C"/>
+                </a:solidFill>
+                <a:latin typeface="Calibri"/>
+                <a:ea typeface="Calibri"/>
+              </a:rPr>
+              <a:t/>
+            </a:r>
+          </a:p>
+          <a:p xmlns:a="http://schemas.openxmlformats.org/drawingml/2006/main">
+            <a:r>
+              <a:rPr lang="en-US" sz="1500" b="0">
+                <a:solidFill>
+                  <a:srgbClr val="1A202C"/>
+                </a:solidFill>
+                <a:latin typeface="Calibri"/>
+                <a:ea typeface="Calibri"/>
+              </a:rPr>
+              <a:t>Design-doc / RFC options table + residual risk</a:t>
+            </a:r>
+          </a:p>
+          <a:p xmlns:a="http://schemas.openxmlformats.org/drawingml/2006/main">
+            <a:r>
+              <a:rPr lang="en-US" sz="1500" b="0">
+                <a:solidFill>
+                  <a:srgbClr val="1A202C"/>
+                </a:solidFill>
+                <a:latin typeface="Calibri"/>
+                <a:ea typeface="Calibri"/>
+              </a:rPr>
+              <a:t/>
+            </a:r>
+          </a:p>
+          <a:p xmlns:a="http://schemas.openxmlformats.org/drawingml/2006/main">
+            <a:r>
+              <a:rPr lang="en-US" sz="1500" b="0">
+                <a:solidFill>
+                  <a:srgbClr val="1A202C"/>
+                </a:solidFill>
+                <a:latin typeface="Calibri"/>
+                <a:ea typeface="Calibri"/>
+              </a:rPr>
+              <a:t>• StaffEng — Writing engineering strategy</a:t>
+            </a:r>
+          </a:p>
+          <a:p xmlns:a="http://schemas.openxmlformats.org/drawingml/2006/main">
+            <a:r>
+              <a:rPr lang="en-US" sz="1500" b="0">
+                <a:solidFill>
+                  <a:srgbClr val="1A202C"/>
+                </a:solidFill>
+                <a:latin typeface="Calibri"/>
+                <a:ea typeface="Calibri"/>
+              </a:rPr>
+              <a:t>  https://staffeng.com/guides/engineering-strategy/</a:t>
+            </a:r>
+          </a:p>
+          <a:p xmlns:a="http://schemas.openxmlformats.org/drawingml/2006/main">
+            <a:r>
+              <a:rPr lang="en-US" sz="1500" b="0">
+                <a:solidFill>
+                  <a:srgbClr val="1A202C"/>
+                </a:solidFill>
+                <a:latin typeface="Calibri"/>
+                <a:ea typeface="Calibri"/>
+              </a:rPr>
+              <a:t>• Utterskills — options instead of single conclusion</a:t>
+            </a:r>
+          </a:p>
+          <a:p xmlns:a="http://schemas.openxmlformats.org/drawingml/2006/main">
+            <a:r>
+              <a:rPr lang="en-US" sz="1500" b="0">
+                <a:solidFill>
+                  <a:srgbClr val="1A202C"/>
+                </a:solidFill>
+                <a:latin typeface="Calibri"/>
+                <a:ea typeface="Calibri"/>
+              </a:rPr>
+              <a:t>  https://utterskills.com/blog/communication-skills-for-software-engineers</a:t>
+            </a:r>
+          </a:p>
+          <a:p xmlns:a="http://schemas.openxmlformats.org/drawingml/2006/main">
+            <a:r>
+              <a:rPr lang="en-US" sz="1500" b="0">
+                <a:solidFill>
+                  <a:srgbClr val="1A202C"/>
+                </a:solidFill>
+                <a:latin typeface="Calibri"/>
+                <a:ea typeface="Calibri"/>
+              </a:rPr>
+              <a:t/>
+            </a:r>
+          </a:p>
+          <a:p xmlns:a="http://schemas.openxmlformats.org/drawingml/2006/main">
+            <a:r>
+              <a:rPr lang="en-US" sz="1500" b="0">
+                <a:solidFill>
+                  <a:srgbClr val="1A202C"/>
+                </a:solidFill>
+                <a:latin typeface="Calibri"/>
+                <a:ea typeface="Calibri"/>
+              </a:rPr>
+              <a:t>How to use: copy section order and decision verbs; replace with your metrics.</a:t>
+            </a:r>
+          </a:p>
+          <a:p xmlns:a="http://schemas.openxmlformats.org/drawingml/2006/main">
+            <a:r>
+              <a:rPr lang="en-US" sz="1500" b="0">
+                <a:solidFill>
+                  <a:srgbClr val="1A202C"/>
+                </a:solidFill>
+                <a:latin typeface="Calibri"/>
+                <a:ea typeface="Calibri"/>
+              </a:rPr>
+              <a:t>In-repo: skills/presentations/classic-public-cases.md</a:t>
+            </a:r>
+          </a:p>
+        </p:txBody>
+      </p:sp>
+      <p:sp>
+        <p:nvSpPr>
+          <p:cNvPr id="100008" name="TextBox 4"/>
+          <p:cNvSpPr txBox="1"/>
+          <p:nvPr/>
+        </p:nvSpPr>
+        <p:spPr>
+          <a:xfrm xmlns:a="http://schemas.openxmlformats.org/drawingml/2006/main">
+            <a:off x="504000" y="6426000"/>
+            <a:ext cx="11088000" cy="306000"/>
+          </a:xfrm>
+          <a:prstGeom xmlns:a="http://schemas.openxmlformats.org/drawingml/2006/main" prst="rect">
+            <a:avLst/>
+          </a:prstGeom>
+        </p:spPr>
+        <p:txBody>
+          <a:bodyPr xmlns:a="http://schemas.openxmlformats.org/drawingml/2006/main"/>
+          <a:lstStyle xmlns:a="http://schemas.openxmlformats.org/drawingml/2006/main"/>
+          <a:p xmlns:a="http://schemas.openxmlformats.org/drawingml/2006/main">
+            <a:r>
+              <a:rPr lang="en-US" sz="1100" b="0">
+                <a:solidFill>
+                  <a:srgbClr val="718096"/>
+                </a:solidFill>
+                <a:latin typeface="Calibri"/>
+                <a:ea typeface="Calibri"/>
+              </a:rPr>
+              <a:t>Atlas Platform  ·  Project Aurora  ·  NovaSemi  ·  2026</a:t>
+            </a:r>
+          </a:p>
+        </p:txBody>
+      </p:sp>
+    </p:spTree>
+  </p:cSld>
+</p:sld>
+</file>
+
+<file path=ppt/slides/slide3.xml><?xml version="1.0" encoding="utf-8"?>
 <p:sld xmlns:p="http://schemas.openxmlformats.org/presentationml/2006/main">
   <p:cSld name="BLUF — approve phased clock mux">
     <p:bg>
@@ -1279,7 +1676,7 @@
       <p:grpSpPr/>
       <p:sp>
         <p:nvSpPr>
-          <p:cNvPr id="100004" name="TextBox 1"/>
+          <p:cNvPr id="100009" name="TextBox 1"/>
           <p:cNvSpPr txBox="1"/>
           <p:nvPr/>
         </p:nvSpPr>
@@ -1311,7 +1708,7 @@
       </p:sp>
       <p:sp>
         <p:nvSpPr>
-          <p:cNvPr id="100005" name="TextBox 2"/>
+          <p:cNvPr id="100010" name="TextBox 2"/>
           <p:cNvSpPr txBox="1"/>
           <p:nvPr/>
         </p:nvSpPr>
@@ -1343,7 +1740,7 @@
       </p:sp>
       <p:sp>
         <p:nvSpPr>
-          <p:cNvPr id="100006" name="TextBox 3"/>
+          <p:cNvPr id="100011" name="TextBox 3"/>
           <p:cNvSpPr txBox="1"/>
           <p:nvPr/>
         </p:nvSpPr>
@@ -1378,7 +1775,7 @@
       </p:sp>
       <p:sp>
         <p:nvSpPr>
-          <p:cNvPr id="100007" name="TextBox 4"/>
+          <p:cNvPr id="100012" name="TextBox 4"/>
           <p:cNvSpPr txBox="1"/>
           <p:nvPr/>
         </p:nvSpPr>
@@ -1485,7 +1882,7 @@
       </p:sp>
       <p:sp>
         <p:nvSpPr>
-          <p:cNvPr id="100008" name="TextBox 5"/>
+          <p:cNvPr id="100013" name="TextBox 5"/>
           <p:cNvSpPr txBox="1"/>
           <p:nvPr/>
         </p:nvSpPr>
@@ -1520,7 +1917,7 @@
 </p:sld>
 </file>
 
-<file path=ppt/slides/slide3.xml><?xml version="1.0" encoding="utf-8"?>
+<file path=ppt/slides/slide4.xml><?xml version="1.0" encoding="utf-8"?>
 <p:sld xmlns:p="http://schemas.openxmlformats.org/presentationml/2006/main">
   <p:cSld name="Problem, goal, constraints">
     <p:bg>
@@ -1539,7 +1936,7 @@
       <p:grpSpPr/>
       <p:sp>
         <p:nvSpPr>
-          <p:cNvPr id="100009" name="TextBox 1"/>
+          <p:cNvPr id="100014" name="TextBox 1"/>
           <p:cNvSpPr txBox="1"/>
           <p:nvPr/>
         </p:nvSpPr>
@@ -1571,7 +1968,7 @@
       </p:sp>
       <p:sp>
         <p:nvSpPr>
-          <p:cNvPr id="100010" name="TextBox 2"/>
+          <p:cNvPr id="100015" name="TextBox 2"/>
           <p:cNvSpPr txBox="1"/>
           <p:nvPr/>
         </p:nvSpPr>
@@ -1654,7 +2051,7 @@
       </p:sp>
       <p:sp>
         <p:nvSpPr>
-          <p:cNvPr id="100011" name="TextBox 3"/>
+          <p:cNvPr id="100016" name="TextBox 3"/>
           <p:cNvSpPr txBox="1"/>
           <p:nvPr/>
         </p:nvSpPr>
@@ -1689,7 +2086,7 @@
 </p:sld>
 </file>
 
-<file path=ppt/slides/slide4.xml><?xml version="1.0" encoding="utf-8"?>
+<file path=ppt/slides/slide5.xml><?xml version="1.0" encoding="utf-8"?>
 <p:sld xmlns:p="http://schemas.openxmlformats.org/presentationml/2006/main">
   <p:cSld name="Design sketch (one page)">
     <p:bg>
@@ -1708,7 +2105,7 @@
       <p:grpSpPr/>
       <p:sp>
         <p:nvSpPr>
-          <p:cNvPr id="100012" name="TextBox 1"/>
+          <p:cNvPr id="100017" name="TextBox 1"/>
           <p:cNvSpPr txBox="1"/>
           <p:nvPr/>
         </p:nvSpPr>
@@ -1740,7 +2137,7 @@
       </p:sp>
       <p:sp>
         <p:nvSpPr>
-          <p:cNvPr id="100013" name="TextBox 2"/>
+          <p:cNvPr id="100018" name="TextBox 2"/>
           <p:cNvSpPr txBox="1"/>
           <p:nvPr/>
         </p:nvSpPr>
@@ -1847,7 +2244,7 @@
       </p:sp>
       <p:sp>
         <p:nvSpPr>
-          <p:cNvPr id="100014" name="TextBox 3"/>
+          <p:cNvPr id="100019" name="TextBox 3"/>
           <p:cNvSpPr txBox="1"/>
           <p:nvPr/>
         </p:nvSpPr>
@@ -1882,7 +2279,7 @@
 </p:sld>
 </file>
 
-<file path=ppt/slides/slide5.xml><?xml version="1.0" encoding="utf-8"?>
+<file path=ppt/slides/slide6.xml><?xml version="1.0" encoding="utf-8"?>
 <p:sld xmlns:p="http://schemas.openxmlformats.org/presentationml/2006/main">
   <p:cSld name="Risks &amp; mitigations (top 3)">
     <p:bg>
@@ -1901,7 +2298,7 @@
       <p:grpSpPr/>
       <p:sp>
         <p:nvSpPr>
-          <p:cNvPr id="100015" name="TextBox 1"/>
+          <p:cNvPr id="100020" name="TextBox 1"/>
           <p:cNvSpPr txBox="1"/>
           <p:nvPr/>
         </p:nvSpPr>
@@ -1933,7 +2330,7 @@
       </p:sp>
       <p:sp>
         <p:nvSpPr>
-          <p:cNvPr id="100016" name="TextBox 2"/>
+          <p:cNvPr id="100021" name="TextBox 2"/>
           <p:cNvSpPr txBox="1"/>
           <p:nvPr/>
         </p:nvSpPr>
@@ -2016,7 +2413,7 @@
       </p:sp>
       <p:sp>
         <p:nvSpPr>
-          <p:cNvPr id="100017" name="TextBox 3"/>
+          <p:cNvPr id="100022" name="TextBox 3"/>
           <p:cNvSpPr txBox="1"/>
           <p:nvPr/>
         </p:nvSpPr>
@@ -2051,7 +2448,7 @@
 </p:sld>
 </file>
 
-<file path=ppt/slides/slide6.xml><?xml version="1.0" encoding="utf-8"?>
+<file path=ppt/slides/slide7.xml><?xml version="1.0" encoding="utf-8"?>
 <p:sld xmlns:p="http://schemas.openxmlformats.org/presentationml/2006/main">
   <p:cSld name="Options &amp; recommendation">
     <p:bg>
@@ -2070,7 +2467,7 @@
       <p:grpSpPr/>
       <p:sp>
         <p:nvSpPr>
-          <p:cNvPr id="100018" name="TextBox 1"/>
+          <p:cNvPr id="100023" name="TextBox 1"/>
           <p:cNvSpPr txBox="1"/>
           <p:nvPr/>
         </p:nvSpPr>
@@ -2102,7 +2499,7 @@
       </p:sp>
       <p:sp>
         <p:nvSpPr>
-          <p:cNvPr id="100019" name="TextBox 2"/>
+          <p:cNvPr id="100024" name="TextBox 2"/>
           <p:cNvSpPr txBox="1"/>
           <p:nvPr/>
         </p:nvSpPr>
@@ -2134,7 +2531,7 @@
       </p:sp>
       <p:graphicFrame>
         <p:nvGraphicFramePr>
-          <p:cNvPr id="100020" name="Table 1"/>
+          <p:cNvPr id="100025" name="Table 1"/>
           <p:cNvGraphicFramePr/>
           <p:nvPr/>
         </p:nvGraphicFramePr>
@@ -2627,7 +3024,7 @@
       </p:graphicFrame>
       <p:sp>
         <p:nvSpPr>
-          <p:cNvPr id="100021" name="TextBox 3"/>
+          <p:cNvPr id="100026" name="TextBox 3"/>
           <p:cNvSpPr txBox="1"/>
           <p:nvPr/>
         </p:nvSpPr>
@@ -2662,7 +3059,7 @@
 </p:sld>
 </file>
 
-<file path=ppt/slides/slide7.xml><?xml version="1.0" encoding="utf-8"?>
+<file path=ppt/slides/slide8.xml><?xml version="1.0" encoding="utf-8"?>
 <p:sld xmlns:p="http://schemas.openxmlformats.org/presentationml/2006/main">
   <p:cSld name="Decision &amp; ask">
     <p:bg>
@@ -2681,7 +3078,7 @@
       <p:grpSpPr/>
       <p:sp>
         <p:nvSpPr>
-          <p:cNvPr id="100022" name="TextBox 1"/>
+          <p:cNvPr id="100027" name="TextBox 1"/>
           <p:cNvSpPr txBox="1"/>
           <p:nvPr/>
         </p:nvSpPr>
@@ -2713,7 +3110,7 @@
       </p:sp>
       <p:sp>
         <p:nvSpPr>
-          <p:cNvPr id="100023" name="TextBox 2"/>
+          <p:cNvPr id="100028" name="TextBox 2"/>
           <p:cNvSpPr txBox="1"/>
           <p:nvPr/>
         </p:nvSpPr>
@@ -2745,7 +3142,7 @@
       </p:sp>
       <p:sp>
         <p:nvSpPr>
-          <p:cNvPr id="100024" name="TextBox 3"/>
+          <p:cNvPr id="100029" name="TextBox 3"/>
           <p:cNvSpPr txBox="1"/>
           <p:nvPr/>
         </p:nvSpPr>
@@ -2828,7 +3225,7 @@
       </p:sp>
       <p:sp>
         <p:nvSpPr>
-          <p:cNvPr id="100025" name="TextBox 4"/>
+          <p:cNvPr id="100030" name="TextBox 4"/>
           <p:cNvSpPr txBox="1"/>
           <p:nvPr/>
         </p:nvSpPr>

</xml_diff>

<commit_message>
Enrich example decks with situation/decision cards and storyline guide
Add EXAMPLE_SITUATIONS for all nine scenarios so cold readers and agents
see presenter, decision-maker, stakes, yes/no, and arc links on a dedicated
slide. Ship storyline-guide.md and extend real-path tests for markers.
</commit_message>
<xml_diff>
--- a/skills/presentations/assets/pptx/examples/01-technical-review.pptx
+++ b/skills/presentations/assets/pptx/examples/01-technical-review.pptx
@@ -5,17 +5,18 @@
     <p:sldMasterId xmlns:r="http://schemas.openxmlformats.org/officeDocument/2006/relationships" id="2147483648" r:id="rId1"/>
   </p:sldMasterIdLst>
   <p:notesMasterIdLst>
-    <p:notesMasterId r:id="R956c1dee84b046f9"/>
+    <p:notesMasterId r:id="R417165bfa6a94b93"/>
   </p:notesMasterIdLst>
   <p:sldIdLst>
-    <p:sldId id="256" r:id="R04e2db6b0334436c"/>
-    <p:sldId id="257" r:id="R4063417af8ac454b"/>
-    <p:sldId id="258" r:id="Re2e05036ed664316"/>
-    <p:sldId id="259" r:id="R434c96df45f74d16"/>
-    <p:sldId id="260" r:id="Re92582b376ed4107"/>
-    <p:sldId id="261" r:id="Raf60c322de6e48e3"/>
-    <p:sldId id="262" r:id="R544065e46e254399"/>
-    <p:sldId id="263" r:id="Rc997902de75946ce"/>
+    <p:sldId id="256" r:id="Rff4ab3b6743b430a"/>
+    <p:sldId id="257" r:id="R5ee899c8ff014982"/>
+    <p:sldId id="258" r:id="R177e170993f74ac4"/>
+    <p:sldId id="259" r:id="R7ed87f69735e47c4"/>
+    <p:sldId id="260" r:id="R60dbc9dd5a624f6e"/>
+    <p:sldId id="261" r:id="Rae41f8c54f8a42ea"/>
+    <p:sldId id="262" r:id="Rac0db253a22144c1"/>
+    <p:sldId id="263" r:id="R7a4d60f178f14fe7"/>
+    <p:sldId id="264" r:id="Rac5242e37c184d73"/>
   </p:sldIdLst>
   <p:sldSz cx="12192000" cy="6858000"/>
   <p:notesSz cx="6858000" cy="9144000"/>
@@ -624,7 +625,7 @@
           <a:p xmlns:a="http://schemas.openxmlformats.org/drawingml/2006/main">
             <a:r>
               <a:rPr lang="en-US"/>
-              <a:t>Land B; do not re-open full dual-mux design in this room.</a:t>
+              <a:t>Agent/human: answer who/stakes/decision from this slide alone. Recommend=Option B — XO-only AON at freeze; dual-source behind DUAL_SRC_EN strap for revB. by 2026-03-20 EOD.</a:t>
             </a:r>
           </a:p>
         </p:txBody>
@@ -679,7 +680,7 @@
           <a:p xmlns:a="http://schemas.openxmlformats.org/drawingml/2006/main">
             <a:r>
               <a:rPr lang="en-US"/>
-              <a:t>Customer SKU power-exit is the business hook.</a:t>
+              <a:t>Land B; do not re-open full dual-mux design in this room.</a:t>
             </a:r>
           </a:p>
         </p:txBody>
@@ -734,7 +735,7 @@
           <a:p xmlns:a="http://schemas.openxmlformats.org/drawingml/2006/main">
             <a:r>
               <a:rPr lang="en-US"/>
-              <a:t>One page; point to RFC-AURORA-117 for waveforms.</a:t>
+              <a:t>Customer SKU power-exit is the business hook.</a:t>
             </a:r>
           </a:p>
         </p:txBody>
@@ -789,7 +790,7 @@
           <a:p xmlns:a="http://schemas.openxmlformats.org/drawingml/2006/main">
             <a:r>
               <a:rPr lang="en-US"/>
-              <a:t>Residual risk is explicit for silicon.</a:t>
+              <a:t>One page; point to RFC-AURORA-117 for waveforms.</a:t>
             </a:r>
           </a:p>
         </p:txBody>
@@ -844,7 +845,7 @@
           <a:p xmlns:a="http://schemas.openxmlformats.org/drawingml/2006/main">
             <a:r>
               <a:rPr lang="en-US"/>
-              <a:t>Walk trade-offs; land recommendation.</a:t>
+              <a:t>Residual risk is explicit for silicon.</a:t>
             </a:r>
           </a:p>
         </p:txBody>
@@ -858,6 +859,61 @@
 </file>
 
 <file path=ppt/notesSlides/notesSlide8.xml><?xml version="1.0" encoding="utf-8"?>
+<p:notes xmlns:p="http://schemas.openxmlformats.org/presentationml/2006/main">
+  <p:cSld>
+    <p:spTree>
+      <p:nvGrpSpPr>
+        <p:cNvPr id="1" name=""/>
+        <p:cNvGrpSpPr/>
+        <p:nvPr/>
+      </p:nvGrpSpPr>
+      <p:grpSpPr>
+        <a:xfrm xmlns:a="http://schemas.openxmlformats.org/drawingml/2006/main"/>
+      </p:grpSpPr>
+      <p:sp>
+        <p:nvSpPr>
+          <p:cNvPr id="2" name="Slide Image Placeholder 1"/>
+          <p:cNvSpPr/>
+          <p:nvPr>
+            <p:ph type="sldImg" idx="0"/>
+          </p:nvPr>
+        </p:nvSpPr>
+        <p:spPr/>
+        <p:txBody>
+          <a:bodyPr xmlns:a="http://schemas.openxmlformats.org/drawingml/2006/main"/>
+          <a:lstStyle xmlns:a="http://schemas.openxmlformats.org/drawingml/2006/main"/>
+          <a:p xmlns:a="http://schemas.openxmlformats.org/drawingml/2006/main"/>
+        </p:txBody>
+      </p:sp>
+      <p:sp>
+        <p:nvSpPr>
+          <p:cNvPr id="3" name="Notes Placeholder 2"/>
+          <p:cNvSpPr/>
+          <p:nvPr>
+            <p:ph type="body" idx="1"/>
+          </p:nvPr>
+        </p:nvSpPr>
+        <p:spPr/>
+        <p:txBody>
+          <a:bodyPr xmlns:a="http://schemas.openxmlformats.org/drawingml/2006/main"/>
+          <a:lstStyle xmlns:a="http://schemas.openxmlformats.org/drawingml/2006/main"/>
+          <a:p xmlns:a="http://schemas.openxmlformats.org/drawingml/2006/main">
+            <a:r>
+              <a:rPr lang="en-US"/>
+              <a:t>Walk trade-offs; land recommendation.</a:t>
+            </a:r>
+          </a:p>
+        </p:txBody>
+      </p:sp>
+    </p:spTree>
+  </p:cSld>
+  <p:clrMapOvr>
+    <a:masterClrMapping xmlns:a="http://schemas.openxmlformats.org/drawingml/2006/main"/>
+  </p:clrMapOvr>
+</p:notes>
+</file>
+
+<file path=ppt/notesSlides/notesSlide9.xml><?xml version="1.0" encoding="utf-8"?>
 <p:notes xmlns:p="http://schemas.openxmlformats.org/presentationml/2006/main">
   <p:cSld>
     <p:spTree>
@@ -1659,6 +1715,387 @@
 
 <file path=ppt/slides/slide3.xml><?xml version="1.0" encoding="utf-8"?>
 <p:sld xmlns:p="http://schemas.openxmlformats.org/presentationml/2006/main">
+  <p:cSld name="Situation &amp; decision card">
+    <p:bg>
+      <p:bgPr>
+        <a:solidFill xmlns:a="http://schemas.openxmlformats.org/drawingml/2006/main">
+          <a:srgbClr val="F4F7FC"/>
+        </a:solidFill>
+      </p:bgPr>
+    </p:bg>
+    <p:spTree>
+      <p:nvGrpSpPr>
+        <p:cNvPr id="1" name=""/>
+        <p:cNvGrpSpPr/>
+        <p:nvPr/>
+      </p:nvGrpSpPr>
+      <p:grpSpPr/>
+      <p:sp>
+        <p:nvSpPr>
+          <p:cNvPr id="100009" name="TextBox 1"/>
+          <p:cNvSpPr txBox="1"/>
+          <p:nvPr/>
+        </p:nvSpPr>
+        <p:spPr>
+          <a:xfrm xmlns:a="http://schemas.openxmlformats.org/drawingml/2006/main">
+            <a:off x="504000" y="270000"/>
+            <a:ext cx="11088000" cy="270000"/>
+          </a:xfrm>
+          <a:prstGeom xmlns:a="http://schemas.openxmlformats.org/drawingml/2006/main" prst="rect">
+            <a:avLst/>
+          </a:prstGeom>
+        </p:spPr>
+        <p:txBody>
+          <a:bodyPr xmlns:a="http://schemas.openxmlformats.org/drawingml/2006/main"/>
+          <a:lstStyle xmlns:a="http://schemas.openxmlformats.org/drawingml/2006/main"/>
+          <a:p xmlns:a="http://schemas.openxmlformats.org/drawingml/2006/main">
+            <a:r>
+              <a:rPr lang="en-US" sz="1100" b="1">
+                <a:solidFill>
+                  <a:srgbClr val="2B6CB0"/>
+                </a:solidFill>
+                <a:latin typeface="Calibri"/>
+                <a:ea typeface="Calibri"/>
+              </a:rPr>
+              <a:t>READ THIS BEFORE THE DETAILS</a:t>
+            </a:r>
+          </a:p>
+        </p:txBody>
+      </p:sp>
+      <p:sp>
+        <p:nvSpPr>
+          <p:cNvPr id="100010" name="TextBox 2"/>
+          <p:cNvSpPr txBox="1"/>
+          <p:nvPr/>
+        </p:nvSpPr>
+        <p:spPr>
+          <a:xfrm xmlns:a="http://schemas.openxmlformats.org/drawingml/2006/main">
+            <a:off x="504000" y="558000"/>
+            <a:ext cx="11088000" cy="612000"/>
+          </a:xfrm>
+          <a:prstGeom xmlns:a="http://schemas.openxmlformats.org/drawingml/2006/main" prst="rect">
+            <a:avLst/>
+          </a:prstGeom>
+        </p:spPr>
+        <p:txBody>
+          <a:bodyPr xmlns:a="http://schemas.openxmlformats.org/drawingml/2006/main"/>
+          <a:lstStyle xmlns:a="http://schemas.openxmlformats.org/drawingml/2006/main"/>
+          <a:p xmlns:a="http://schemas.openxmlformats.org/drawingml/2006/main">
+            <a:r>
+              <a:rPr lang="en-US" sz="2800" b="1">
+                <a:solidFill>
+                  <a:srgbClr val="1A202C"/>
+                </a:solidFill>
+                <a:latin typeface="Calibri"/>
+                <a:ea typeface="Calibri"/>
+              </a:rPr>
+              <a:t>Situation &amp; decision card</a:t>
+            </a:r>
+          </a:p>
+        </p:txBody>
+      </p:sp>
+      <p:sp>
+        <p:nvSpPr>
+          <p:cNvPr id="100011" name="TextBox 3"/>
+          <p:cNvSpPr txBox="1"/>
+          <p:nvPr/>
+        </p:nvSpPr>
+        <p:spPr>
+          <a:xfrm xmlns:a="http://schemas.openxmlformats.org/drawingml/2006/main">
+            <a:off x="504000" y="1224000"/>
+            <a:ext cx="11088000" cy="4968000"/>
+          </a:xfrm>
+          <a:prstGeom xmlns:a="http://schemas.openxmlformats.org/drawingml/2006/main" prst="rect">
+            <a:avLst/>
+          </a:prstGeom>
+          <a:solidFill xmlns:a="http://schemas.openxmlformats.org/drawingml/2006/main">
+            <a:srgbClr val="FFFFFF"/>
+          </a:solidFill>
+        </p:spPr>
+        <p:txBody>
+          <a:bodyPr xmlns:a="http://schemas.openxmlformats.org/drawingml/2006/main"/>
+          <a:lstStyle xmlns:a="http://schemas.openxmlformats.org/drawingml/2006/main"/>
+          <a:p xmlns:a="http://schemas.openxmlformats.org/drawingml/2006/main">
+            <a:r>
+              <a:rPr lang="en-US" sz="1300" b="0">
+                <a:solidFill>
+                  <a:srgbClr val="1A202C"/>
+                </a:solidFill>
+                <a:latin typeface="Calibri"/>
+                <a:ea typeface="Calibri"/>
+              </a:rPr>
+              <a:t>Presenter: Alex Chen — EM, Atlas Platform (NovaSemi)</a:t>
+            </a:r>
+          </a:p>
+          <a:p xmlns:a="http://schemas.openxmlformats.org/drawingml/2006/main">
+            <a:r>
+              <a:rPr lang="en-US" sz="1300" b="0">
+                <a:solidFill>
+                  <a:srgbClr val="1A202C"/>
+                </a:solidFill>
+                <a:latin typeface="Calibri"/>
+                <a:ea typeface="Calibri"/>
+              </a:rPr>
+              <a:t>Decision-maker: Morgan Lee — VP Engineering (final call on freeze architecture)</a:t>
+            </a:r>
+          </a:p>
+          <a:p xmlns:a="http://schemas.openxmlformats.org/drawingml/2006/main">
+            <a:r>
+              <a:rPr lang="en-US" sz="1300" b="0">
+                <a:solidFill>
+                  <a:srgbClr val="1A202C"/>
+                </a:solidFill>
+                <a:latin typeface="Calibri"/>
+                <a:ea typeface="Calibri"/>
+              </a:rPr>
+              <a:t>Audience: VP Eng + clock/analog/DV leads; PMIC IP liaison Ken optional</a:t>
+            </a:r>
+          </a:p>
+          <a:p xmlns:a="http://schemas.openxmlformats.org/drawingml/2006/main">
+            <a:r>
+              <a:rPr lang="en-US" sz="1300" b="0">
+                <a:solidFill>
+                  <a:srgbClr val="1A202C"/>
+                </a:solidFill>
+                <a:latin typeface="Calibri"/>
+                <a:ea typeface="Calibri"/>
+              </a:rPr>
+              <a:t/>
+            </a:r>
+          </a:p>
+          <a:p xmlns:a="http://schemas.openxmlformats.org/drawingml/2006/main">
+            <a:r>
+              <a:rPr lang="en-US" sz="1300" b="0">
+                <a:solidFill>
+                  <a:srgbClr val="1A202C"/>
+                </a:solidFill>
+                <a:latin typeface="Calibri"/>
+                <a:ea typeface="Calibri"/>
+              </a:rPr>
+              <a:t>What just happened / context:</a:t>
+            </a:r>
+          </a:p>
+          <a:p xmlns:a="http://schemas.openxmlformats.org/drawingml/2006/main">
+            <a:r>
+              <a:rPr lang="en-US" sz="1300" b="0">
+                <a:solidFill>
+                  <a:srgbClr val="1A202C"/>
+                </a:solidFill>
+                <a:latin typeface="Calibri"/>
+                <a:ea typeface="Calibri"/>
+              </a:rPr>
+              <a:t>Aurora AON clock architecture is still open 3 weeks before RTL freeze 2026-04-10. Full dual-source glitchless mux needs +3 eng-weeks and puts freeze at risk. DV cannot lock sleep-exit assertions until the architecture is frozen.</a:t>
+            </a:r>
+          </a:p>
+          <a:p xmlns:a="http://schemas.openxmlformats.org/drawingml/2006/main">
+            <a:r>
+              <a:rPr lang="en-US" sz="1300" b="0">
+                <a:solidFill>
+                  <a:srgbClr val="1A202C"/>
+                </a:solidFill>
+                <a:latin typeface="Calibri"/>
+                <a:ea typeface="Calibri"/>
+              </a:rPr>
+              <a:t/>
+            </a:r>
+          </a:p>
+          <a:p xmlns:a="http://schemas.openxmlformats.org/drawingml/2006/main">
+            <a:r>
+              <a:rPr lang="en-US" sz="1300" b="0">
+                <a:solidFill>
+                  <a:srgbClr val="1A202C"/>
+                </a:solidFill>
+                <a:latin typeface="Calibri"/>
+                <a:ea typeface="Calibri"/>
+              </a:rPr>
+              <a:t>Stakes if we get this wrong:</a:t>
+            </a:r>
+          </a:p>
+          <a:p xmlns:a="http://schemas.openxmlformats.org/drawingml/2006/main">
+            <a:r>
+              <a:rPr lang="en-US" sz="1300" b="0">
+                <a:solidFill>
+                  <a:srgbClr val="1A202C"/>
+                </a:solidFill>
+                <a:latin typeface="Calibri"/>
+                <a:ea typeface="Calibri"/>
+              </a:rPr>
+              <a:t>If freeze slips: tape-out and first-silicon slip → Tier-1 sample window for 6/30 compresses. If we ship dual mux unfinished: brown-out risk on deep-sleep exit for mobile SKUs.</a:t>
+            </a:r>
+          </a:p>
+          <a:p xmlns:a="http://schemas.openxmlformats.org/drawingml/2006/main">
+            <a:r>
+              <a:rPr lang="en-US" sz="1300" b="0">
+                <a:solidFill>
+                  <a:srgbClr val="1A202C"/>
+                </a:solidFill>
+                <a:latin typeface="Calibri"/>
+                <a:ea typeface="Calibri"/>
+              </a:rPr>
+              <a:t/>
+            </a:r>
+          </a:p>
+          <a:p xmlns:a="http://schemas.openxmlformats.org/drawingml/2006/main">
+            <a:r>
+              <a:rPr lang="en-US" sz="1300" b="0">
+                <a:solidFill>
+                  <a:srgbClr val="1A202C"/>
+                </a:solidFill>
+                <a:latin typeface="Calibri"/>
+                <a:ea typeface="Calibri"/>
+              </a:rPr>
+              <a:t>Decision needed:</a:t>
+            </a:r>
+          </a:p>
+          <a:p xmlns:a="http://schemas.openxmlformats.org/drawingml/2006/main">
+            <a:r>
+              <a:rPr lang="en-US" sz="1300" b="0">
+                <a:solidFill>
+                  <a:srgbClr val="1A202C"/>
+                </a:solidFill>
+                <a:latin typeface="Calibri"/>
+                <a:ea typeface="Calibri"/>
+              </a:rPr>
+              <a:t>Choose AON clock path for freeze: A full dual mux now / B phased strap (REC) / C keep dual unfinished in RTL.</a:t>
+            </a:r>
+          </a:p>
+          <a:p xmlns:a="http://schemas.openxmlformats.org/drawingml/2006/main">
+            <a:r>
+              <a:rPr lang="en-US" sz="1300" b="0">
+                <a:solidFill>
+                  <a:srgbClr val="1A202C"/>
+                </a:solidFill>
+                <a:latin typeface="Calibri"/>
+                <a:ea typeface="Calibri"/>
+              </a:rPr>
+              <a:t/>
+            </a:r>
+          </a:p>
+          <a:p xmlns:a="http://schemas.openxmlformats.org/drawingml/2006/main">
+            <a:r>
+              <a:rPr lang="en-US" sz="1300" b="0">
+                <a:solidFill>
+                  <a:srgbClr val="1A202C"/>
+                </a:solidFill>
+                <a:latin typeface="Calibri"/>
+                <a:ea typeface="Calibri"/>
+              </a:rPr>
+              <a:t>Recommendation: Option B — XO-only AON at freeze; dual-source behind DUAL_SRC_EN strap for revB.</a:t>
+            </a:r>
+          </a:p>
+          <a:p xmlns:a="http://schemas.openxmlformats.org/drawingml/2006/main">
+            <a:r>
+              <a:rPr lang="en-US" sz="1300" b="0">
+                <a:solidFill>
+                  <a:srgbClr val="1A202C"/>
+                </a:solidFill>
+                <a:latin typeface="Calibri"/>
+                <a:ea typeface="Calibri"/>
+              </a:rPr>
+              <a:t>If YES: Freeze 4/10 holds; DV locks assertions; revB dual-mux enters H2 roadmap.</a:t>
+            </a:r>
+          </a:p>
+          <a:p xmlns:a="http://schemas.openxmlformats.org/drawingml/2006/main">
+            <a:r>
+              <a:rPr lang="en-US" sz="1300" b="0">
+                <a:solidFill>
+                  <a:srgbClr val="1A202C"/>
+                </a:solidFill>
+                <a:latin typeface="Calibri"/>
+                <a:ea typeface="Calibri"/>
+              </a:rPr>
+              <a:t>If NO / delay: Default C = freeze slip risk accepted; or A burns +3 eng-wk and still may miss 4/10.</a:t>
+            </a:r>
+          </a:p>
+          <a:p xmlns:a="http://schemas.openxmlformats.org/drawingml/2006/main">
+            <a:r>
+              <a:rPr lang="en-US" sz="1300" b="0">
+                <a:solidFill>
+                  <a:srgbClr val="1A202C"/>
+                </a:solidFill>
+                <a:latin typeface="Calibri"/>
+                <a:ea typeface="Calibri"/>
+              </a:rPr>
+              <a:t/>
+            </a:r>
+          </a:p>
+          <a:p xmlns:a="http://schemas.openxmlformats.org/drawingml/2006/main">
+            <a:r>
+              <a:rPr lang="en-US" sz="1300" b="0">
+                <a:solidFill>
+                  <a:srgbClr val="1A202C"/>
+                </a:solidFill>
+                <a:latin typeface="Calibri"/>
+                <a:ea typeface="Calibri"/>
+              </a:rPr>
+              <a:t>Decide by: 2026-03-20 EOD</a:t>
+            </a:r>
+          </a:p>
+          <a:p xmlns:a="http://schemas.openxmlformats.org/drawingml/2006/main">
+            <a:r>
+              <a:rPr lang="en-US" sz="1300" b="0">
+                <a:solidFill>
+                  <a:srgbClr val="1A202C"/>
+                </a:solidFill>
+                <a:latin typeface="Calibri"/>
+                <a:ea typeface="Calibri"/>
+              </a:rPr>
+              <a:t>Arc prior: (arc start) no prior deck</a:t>
+            </a:r>
+          </a:p>
+          <a:p xmlns:a="http://schemas.openxmlformats.org/drawingml/2006/main">
+            <a:r>
+              <a:rPr lang="en-US" sz="1300" b="0">
+                <a:solidFill>
+                  <a:srgbClr val="1A202C"/>
+                </a:solidFill>
+                <a:latin typeface="Calibri"/>
+                <a:ea typeface="Calibri"/>
+              </a:rPr>
+              <a:t>Arc next: 02 results after first silicon if freeze holds → day-3 boot story</a:t>
+            </a:r>
+          </a:p>
+        </p:txBody>
+      </p:sp>
+      <p:sp>
+        <p:nvSpPr>
+          <p:cNvPr id="100012" name="TextBox 4"/>
+          <p:cNvSpPr txBox="1"/>
+          <p:nvPr/>
+        </p:nvSpPr>
+        <p:spPr>
+          <a:xfrm xmlns:a="http://schemas.openxmlformats.org/drawingml/2006/main">
+            <a:off x="504000" y="6426000"/>
+            <a:ext cx="11088000" cy="306000"/>
+          </a:xfrm>
+          <a:prstGeom xmlns:a="http://schemas.openxmlformats.org/drawingml/2006/main" prst="rect">
+            <a:avLst/>
+          </a:prstGeom>
+        </p:spPr>
+        <p:txBody>
+          <a:bodyPr xmlns:a="http://schemas.openxmlformats.org/drawingml/2006/main"/>
+          <a:lstStyle xmlns:a="http://schemas.openxmlformats.org/drawingml/2006/main"/>
+          <a:p xmlns:a="http://schemas.openxmlformats.org/drawingml/2006/main">
+            <a:r>
+              <a:rPr lang="en-US" sz="1100" b="0">
+                <a:solidFill>
+                  <a:srgbClr val="718096"/>
+                </a:solidFill>
+                <a:latin typeface="Calibri"/>
+                <a:ea typeface="Calibri"/>
+              </a:rPr>
+              <a:t>Atlas Platform  ·  Project Aurora  ·  NovaSemi  ·  2026</a:t>
+            </a:r>
+          </a:p>
+        </p:txBody>
+      </p:sp>
+    </p:spTree>
+  </p:cSld>
+</p:sld>
+</file>
+
+<file path=ppt/slides/slide4.xml><?xml version="1.0" encoding="utf-8"?>
+<p:sld xmlns:p="http://schemas.openxmlformats.org/presentationml/2006/main">
   <p:cSld name="BLUF — approve phased clock mux">
     <p:bg>
       <p:bgPr>
@@ -1676,7 +2113,7 @@
       <p:grpSpPr/>
       <p:sp>
         <p:nvSpPr>
-          <p:cNvPr id="100009" name="TextBox 1"/>
+          <p:cNvPr id="100013" name="TextBox 1"/>
           <p:cNvSpPr txBox="1"/>
           <p:nvPr/>
         </p:nvSpPr>
@@ -1708,7 +2145,7 @@
       </p:sp>
       <p:sp>
         <p:nvSpPr>
-          <p:cNvPr id="100010" name="TextBox 2"/>
+          <p:cNvPr id="100014" name="TextBox 2"/>
           <p:cNvSpPr txBox="1"/>
           <p:nvPr/>
         </p:nvSpPr>
@@ -1740,7 +2177,7 @@
       </p:sp>
       <p:sp>
         <p:nvSpPr>
-          <p:cNvPr id="100011" name="TextBox 3"/>
+          <p:cNvPr id="100015" name="TextBox 3"/>
           <p:cNvSpPr txBox="1"/>
           <p:nvPr/>
         </p:nvSpPr>
@@ -1775,7 +2212,7 @@
       </p:sp>
       <p:sp>
         <p:nvSpPr>
-          <p:cNvPr id="100012" name="TextBox 4"/>
+          <p:cNvPr id="100016" name="TextBox 4"/>
           <p:cNvSpPr txBox="1"/>
           <p:nvPr/>
         </p:nvSpPr>
@@ -1882,7 +2319,7 @@
       </p:sp>
       <p:sp>
         <p:nvSpPr>
-          <p:cNvPr id="100013" name="TextBox 5"/>
+          <p:cNvPr id="100017" name="TextBox 5"/>
           <p:cNvSpPr txBox="1"/>
           <p:nvPr/>
         </p:nvSpPr>
@@ -1917,7 +2354,7 @@
 </p:sld>
 </file>
 
-<file path=ppt/slides/slide4.xml><?xml version="1.0" encoding="utf-8"?>
+<file path=ppt/slides/slide5.xml><?xml version="1.0" encoding="utf-8"?>
 <p:sld xmlns:p="http://schemas.openxmlformats.org/presentationml/2006/main">
   <p:cSld name="Problem, goal, constraints">
     <p:bg>
@@ -1936,7 +2373,7 @@
       <p:grpSpPr/>
       <p:sp>
         <p:nvSpPr>
-          <p:cNvPr id="100014" name="TextBox 1"/>
+          <p:cNvPr id="100018" name="TextBox 1"/>
           <p:cNvSpPr txBox="1"/>
           <p:nvPr/>
         </p:nvSpPr>
@@ -1968,7 +2405,7 @@
       </p:sp>
       <p:sp>
         <p:nvSpPr>
-          <p:cNvPr id="100015" name="TextBox 2"/>
+          <p:cNvPr id="100019" name="TextBox 2"/>
           <p:cNvSpPr txBox="1"/>
           <p:nvPr/>
         </p:nvSpPr>
@@ -2051,7 +2488,7 @@
       </p:sp>
       <p:sp>
         <p:nvSpPr>
-          <p:cNvPr id="100016" name="TextBox 3"/>
+          <p:cNvPr id="100020" name="TextBox 3"/>
           <p:cNvSpPr txBox="1"/>
           <p:nvPr/>
         </p:nvSpPr>
@@ -2086,7 +2523,7 @@
 </p:sld>
 </file>
 
-<file path=ppt/slides/slide5.xml><?xml version="1.0" encoding="utf-8"?>
+<file path=ppt/slides/slide6.xml><?xml version="1.0" encoding="utf-8"?>
 <p:sld xmlns:p="http://schemas.openxmlformats.org/presentationml/2006/main">
   <p:cSld name="Design sketch (one page)">
     <p:bg>
@@ -2105,7 +2542,7 @@
       <p:grpSpPr/>
       <p:sp>
         <p:nvSpPr>
-          <p:cNvPr id="100017" name="TextBox 1"/>
+          <p:cNvPr id="100021" name="TextBox 1"/>
           <p:cNvSpPr txBox="1"/>
           <p:nvPr/>
         </p:nvSpPr>
@@ -2137,7 +2574,7 @@
       </p:sp>
       <p:sp>
         <p:nvSpPr>
-          <p:cNvPr id="100018" name="TextBox 2"/>
+          <p:cNvPr id="100022" name="TextBox 2"/>
           <p:cNvSpPr txBox="1"/>
           <p:nvPr/>
         </p:nvSpPr>
@@ -2244,7 +2681,7 @@
       </p:sp>
       <p:sp>
         <p:nvSpPr>
-          <p:cNvPr id="100019" name="TextBox 3"/>
+          <p:cNvPr id="100023" name="TextBox 3"/>
           <p:cNvSpPr txBox="1"/>
           <p:nvPr/>
         </p:nvSpPr>
@@ -2279,7 +2716,7 @@
 </p:sld>
 </file>
 
-<file path=ppt/slides/slide6.xml><?xml version="1.0" encoding="utf-8"?>
+<file path=ppt/slides/slide7.xml><?xml version="1.0" encoding="utf-8"?>
 <p:sld xmlns:p="http://schemas.openxmlformats.org/presentationml/2006/main">
   <p:cSld name="Risks &amp; mitigations (top 3)">
     <p:bg>
@@ -2298,7 +2735,7 @@
       <p:grpSpPr/>
       <p:sp>
         <p:nvSpPr>
-          <p:cNvPr id="100020" name="TextBox 1"/>
+          <p:cNvPr id="100024" name="TextBox 1"/>
           <p:cNvSpPr txBox="1"/>
           <p:nvPr/>
         </p:nvSpPr>
@@ -2330,7 +2767,7 @@
       </p:sp>
       <p:sp>
         <p:nvSpPr>
-          <p:cNvPr id="100021" name="TextBox 2"/>
+          <p:cNvPr id="100025" name="TextBox 2"/>
           <p:cNvSpPr txBox="1"/>
           <p:nvPr/>
         </p:nvSpPr>
@@ -2413,7 +2850,7 @@
       </p:sp>
       <p:sp>
         <p:nvSpPr>
-          <p:cNvPr id="100022" name="TextBox 3"/>
+          <p:cNvPr id="100026" name="TextBox 3"/>
           <p:cNvSpPr txBox="1"/>
           <p:nvPr/>
         </p:nvSpPr>
@@ -2448,7 +2885,7 @@
 </p:sld>
 </file>
 
-<file path=ppt/slides/slide7.xml><?xml version="1.0" encoding="utf-8"?>
+<file path=ppt/slides/slide8.xml><?xml version="1.0" encoding="utf-8"?>
 <p:sld xmlns:p="http://schemas.openxmlformats.org/presentationml/2006/main">
   <p:cSld name="Options &amp; recommendation">
     <p:bg>
@@ -2467,7 +2904,7 @@
       <p:grpSpPr/>
       <p:sp>
         <p:nvSpPr>
-          <p:cNvPr id="100023" name="TextBox 1"/>
+          <p:cNvPr id="100027" name="TextBox 1"/>
           <p:cNvSpPr txBox="1"/>
           <p:nvPr/>
         </p:nvSpPr>
@@ -2499,7 +2936,7 @@
       </p:sp>
       <p:sp>
         <p:nvSpPr>
-          <p:cNvPr id="100024" name="TextBox 2"/>
+          <p:cNvPr id="100028" name="TextBox 2"/>
           <p:cNvSpPr txBox="1"/>
           <p:nvPr/>
         </p:nvSpPr>
@@ -2531,7 +2968,7 @@
       </p:sp>
       <p:graphicFrame>
         <p:nvGraphicFramePr>
-          <p:cNvPr id="100025" name="Table 1"/>
+          <p:cNvPr id="100029" name="Table 1"/>
           <p:cNvGraphicFramePr/>
           <p:nvPr/>
         </p:nvGraphicFramePr>
@@ -3024,7 +3461,7 @@
       </p:graphicFrame>
       <p:sp>
         <p:nvSpPr>
-          <p:cNvPr id="100026" name="TextBox 3"/>
+          <p:cNvPr id="100030" name="TextBox 3"/>
           <p:cNvSpPr txBox="1"/>
           <p:nvPr/>
         </p:nvSpPr>
@@ -3059,7 +3496,7 @@
 </p:sld>
 </file>
 
-<file path=ppt/slides/slide8.xml><?xml version="1.0" encoding="utf-8"?>
+<file path=ppt/slides/slide9.xml><?xml version="1.0" encoding="utf-8"?>
 <p:sld xmlns:p="http://schemas.openxmlformats.org/presentationml/2006/main">
   <p:cSld name="Decision &amp; ask">
     <p:bg>
@@ -3078,7 +3515,7 @@
       <p:grpSpPr/>
       <p:sp>
         <p:nvSpPr>
-          <p:cNvPr id="100027" name="TextBox 1"/>
+          <p:cNvPr id="100031" name="TextBox 1"/>
           <p:cNvSpPr txBox="1"/>
           <p:nvPr/>
         </p:nvSpPr>
@@ -3110,7 +3547,7 @@
       </p:sp>
       <p:sp>
         <p:nvSpPr>
-          <p:cNvPr id="100028" name="TextBox 2"/>
+          <p:cNvPr id="100032" name="TextBox 2"/>
           <p:cNvSpPr txBox="1"/>
           <p:nvPr/>
         </p:nvSpPr>
@@ -3142,7 +3579,7 @@
       </p:sp>
       <p:sp>
         <p:nvSpPr>
-          <p:cNvPr id="100029" name="TextBox 3"/>
+          <p:cNvPr id="100033" name="TextBox 3"/>
           <p:cNvSpPr txBox="1"/>
           <p:nvPr/>
         </p:nvSpPr>
@@ -3225,7 +3662,7 @@
       </p:sp>
       <p:sp>
         <p:nvSpPr>
-          <p:cNvPr id="100030" name="TextBox 4"/>
+          <p:cNvPr id="100034" name="TextBox 4"/>
           <p:cNvSpPr txBox="1"/>
           <p:nvPr/>
         </p:nvSpPr>

</xml_diff>

<commit_message>
Fix inverted prior_arc chronology on example decks 05 and 09
Correct 09 prior (no 01→08), 05 prior (no 02/09), and add
AURORA_PRESENTATION_ORDER tests so inverted arcs fail CI. Regenerate
example PPTX with Situation card arcs.
</commit_message>
<xml_diff>
--- a/skills/presentations/assets/pptx/examples/01-technical-review.pptx
+++ b/skills/presentations/assets/pptx/examples/01-technical-review.pptx
@@ -5,18 +5,18 @@
     <p:sldMasterId xmlns:r="http://schemas.openxmlformats.org/officeDocument/2006/relationships" id="2147483648" r:id="rId1"/>
   </p:sldMasterIdLst>
   <p:notesMasterIdLst>
-    <p:notesMasterId r:id="R417165bfa6a94b93"/>
+    <p:notesMasterId r:id="R810a59423db44f83"/>
   </p:notesMasterIdLst>
   <p:sldIdLst>
-    <p:sldId id="256" r:id="Rff4ab3b6743b430a"/>
-    <p:sldId id="257" r:id="R5ee899c8ff014982"/>
-    <p:sldId id="258" r:id="R177e170993f74ac4"/>
-    <p:sldId id="259" r:id="R7ed87f69735e47c4"/>
-    <p:sldId id="260" r:id="R60dbc9dd5a624f6e"/>
-    <p:sldId id="261" r:id="Rae41f8c54f8a42ea"/>
-    <p:sldId id="262" r:id="Rac0db253a22144c1"/>
-    <p:sldId id="263" r:id="R7a4d60f178f14fe7"/>
-    <p:sldId id="264" r:id="Rac5242e37c184d73"/>
+    <p:sldId id="256" r:id="Rbe0c1748b6ae448b"/>
+    <p:sldId id="257" r:id="R249c9463f16e4cd6"/>
+    <p:sldId id="258" r:id="R60787d27e83c4b1f"/>
+    <p:sldId id="259" r:id="R1ba9567cd17d4b09"/>
+    <p:sldId id="260" r:id="R66234c9da55d4b3a"/>
+    <p:sldId id="261" r:id="R42d3cd80cd384018"/>
+    <p:sldId id="262" r:id="R0cf2001028304dfc"/>
+    <p:sldId id="263" r:id="R350ea87721684578"/>
+    <p:sldId id="264" r:id="R50467e6a2e154ca9"/>
   </p:sldIdLst>
   <p:sldSz cx="12192000" cy="6858000"/>
   <p:notesSz cx="6858000" cy="9144000"/>

</xml_diff>

<commit_message>
Label presentation assets as content templates, not design systems
Document for agents and humans that sample PPTX teach narrative and
decision structure only; do not copy visual layout, colors, or masters.
</commit_message>
<xml_diff>
--- a/skills/presentations/assets/pptx/examples/01-technical-review.pptx
+++ b/skills/presentations/assets/pptx/examples/01-technical-review.pptx
@@ -5,18 +5,18 @@
     <p:sldMasterId xmlns:r="http://schemas.openxmlformats.org/officeDocument/2006/relationships" id="2147483648" r:id="rId1"/>
   </p:sldMasterIdLst>
   <p:notesMasterIdLst>
-    <p:notesMasterId r:id="R810a59423db44f83"/>
+    <p:notesMasterId r:id="R6c1e107876f8486a"/>
   </p:notesMasterIdLst>
   <p:sldIdLst>
-    <p:sldId id="256" r:id="Rbe0c1748b6ae448b"/>
-    <p:sldId id="257" r:id="R249c9463f16e4cd6"/>
-    <p:sldId id="258" r:id="R60787d27e83c4b1f"/>
-    <p:sldId id="259" r:id="R1ba9567cd17d4b09"/>
-    <p:sldId id="260" r:id="R66234c9da55d4b3a"/>
-    <p:sldId id="261" r:id="R42d3cd80cd384018"/>
-    <p:sldId id="262" r:id="R0cf2001028304dfc"/>
-    <p:sldId id="263" r:id="R350ea87721684578"/>
-    <p:sldId id="264" r:id="R50467e6a2e154ca9"/>
+    <p:sldId id="256" r:id="Rbe27270b92b04008"/>
+    <p:sldId id="257" r:id="Rd9226f3a74d64fb2"/>
+    <p:sldId id="258" r:id="Rdf3c969a322b4d23"/>
+    <p:sldId id="259" r:id="R2243f931d51b4738"/>
+    <p:sldId id="260" r:id="Rc94499aa541c44f6"/>
+    <p:sldId id="261" r:id="R381e9eac75114591"/>
+    <p:sldId id="262" r:id="R5d3c8f36dd3647e5"/>
+    <p:sldId id="263" r:id="R6335997743034091"/>
+    <p:sldId id="264" r:id="Rdd57a504e96e43aa"/>
   </p:sldIdLst>
   <p:sldSz cx="12192000" cy="6858000"/>
   <p:notesSz cx="6858000" cy="9144000"/>
@@ -1671,7 +1671,19 @@
                 <a:latin typeface="Calibri"/>
                 <a:ea typeface="Calibri"/>
               </a:rPr>
-              <a:t>In-repo: skills/presentations/classic-public-cases.md</a:t>
+              <a:t>CONTENT TEMPLATE ONLY — do not copy visual design (colors, margins, fonts) as a brand system.</a:t>
+            </a:r>
+          </a:p>
+          <a:p xmlns:a="http://schemas.openxmlformats.org/drawingml/2006/main">
+            <a:r>
+              <a:rPr lang="en-US" sz="1500" b="0">
+                <a:solidFill>
+                  <a:srgbClr val="1A202C"/>
+                </a:solidFill>
+                <a:latin typeface="Calibri"/>
+                <a:ea typeface="Calibri"/>
+              </a:rPr>
+              <a:t>In-repo: skills/presentations/classic-public-cases.md · assets/README.md (agent notice)</a:t>
             </a:r>
           </a:p>
         </p:txBody>

</xml_diff>